<commit_message>
Poster: plainer look (black text, simple table, no divider lines)
Co-Authored-By: Claude Opus 5.5 <noreply@anthropic.com>
Claude-Session: https://claude.ai/code/session_01Y78JcsHaGmWfortdHv7ra9
</commit_message>
<xml_diff>
--- a/poster/Poster_Geneigte_Ebene.pptx
+++ b/poster/Poster_Geneigte_Ebene.pptx
@@ -3110,7 +3110,7 @@
           </a:bodyPr>
           <a:lstStyle/>
           <a:p>
-            <a:pPr algn="l">
+            <a:pPr algn="ctr">
               <a:spcAft>
                 <a:spcPts val="400"/>
               </a:spcAft>
@@ -3118,7 +3118,7 @@
             <a:r>
               <a:rPr sz="6000" b="1">
                 <a:solidFill>
-                  <a:srgbClr val="222222"/>
+                  <a:srgbClr val="000000"/>
                 </a:solidFill>
                 <a:latin typeface="Arial"/>
               </a:rPr>
@@ -3149,7 +3149,7 @@
           </a:bodyPr>
           <a:lstStyle/>
           <a:p>
-            <a:pPr algn="l">
+            <a:pPr algn="ctr">
               <a:spcAft>
                 <a:spcPts val="400"/>
               </a:spcAft>
@@ -3157,11 +3157,11 @@
             <a:r>
               <a:rPr sz="3000" b="0">
                 <a:solidFill>
-                  <a:srgbClr val="1F6FB2"/>
+                  <a:srgbClr val="000000"/>
                 </a:solidFill>
                 <a:latin typeface="Arial"/>
               </a:rPr>
-              <a:t>Goldene Regel der Mechanik</a:t>
+              <a:t>und die Goldene Regel der Mechanik</a:t>
             </a:r>
           </a:p>
         </p:txBody>
@@ -3174,7 +3174,7 @@
         </p:nvSpPr>
         <p:spPr>
           <a:xfrm>
-            <a:off x="540000" y="1764000"/>
+            <a:off x="540000" y="1800000"/>
             <a:ext cx="9612000" cy="288000"/>
           </a:xfrm>
           <a:prstGeom prst="rect">
@@ -3188,62 +3188,33 @@
           </a:bodyPr>
           <a:lstStyle/>
           <a:p>
-            <a:pPr algn="l">
+            <a:pPr algn="ctr">
               <a:spcAft>
                 <a:spcPts val="400"/>
               </a:spcAft>
             </a:pPr>
             <a:r>
-              <a:rPr sz="1400" b="0">
-                <a:solidFill>
-                  <a:srgbClr val="888888"/>
+              <a:rPr sz="1600" b="0">
+                <a:solidFill>
+                  <a:srgbClr val="000000"/>
                 </a:solidFill>
                 <a:latin typeface="Arial"/>
               </a:rPr>
-              <a:t>Can, Antonio, Florian, Philly  ·  MCG</a:t>
-            </a:r>
-          </a:p>
-        </p:txBody>
-      </p:sp>
-      <p:sp>
-        <p:nvSpPr>
-          <p:cNvPr id="5" name="Rectangle 4"/>
-          <p:cNvSpPr/>
+              <a:t>von Can, Antonio, Florian und Philly (MCG)</a:t>
+            </a:r>
+          </a:p>
+        </p:txBody>
+      </p:sp>
+      <p:sp>
+        <p:nvSpPr>
+          <p:cNvPr id="5" name="TextBox 4"/>
+          <p:cNvSpPr txBox="1"/>
           <p:nvPr/>
         </p:nvSpPr>
         <p:spPr>
           <a:xfrm>
-            <a:off x="540000" y="2124000"/>
-            <a:ext cx="9612000" cy="43200"/>
-          </a:xfrm>
-          <a:prstGeom prst="rect">
-            <a:avLst/>
-          </a:prstGeom>
-          <a:solidFill>
-            <a:srgbClr val="1F6FB2"/>
-          </a:solidFill>
-          <a:ln>
-            <a:noFill/>
-          </a:ln>
-        </p:spPr>
-        <p:txBody>
-          <a:bodyPr rtlCol="0" anchor="ctr"/>
-          <a:lstStyle/>
-          <a:p>
-            <a:pPr algn="ctr"/>
-          </a:p>
-        </p:txBody>
-      </p:sp>
-      <p:sp>
-        <p:nvSpPr>
-          <p:cNvPr id="6" name="TextBox 5"/>
-          <p:cNvSpPr txBox="1"/>
-          <p:nvPr/>
-        </p:nvSpPr>
-        <p:spPr>
-          <a:xfrm>
-            <a:off x="540000" y="2376000"/>
-            <a:ext cx="4662000" cy="432000"/>
+            <a:off x="540000" y="2448000"/>
+            <a:ext cx="4626000" cy="432000"/>
           </a:xfrm>
           <a:prstGeom prst="rect">
             <a:avLst/>
@@ -3262,9 +3233,9 @@
               </a:spcAft>
             </a:pPr>
             <a:r>
-              <a:rPr sz="2600" b="1">
-                <a:solidFill>
-                  <a:srgbClr val="1F6FB2"/>
+              <a:rPr sz="2800" b="1">
+                <a:solidFill>
+                  <a:srgbClr val="000000"/>
                 </a:solidFill>
                 <a:latin typeface="Arial"/>
               </a:rPr>
@@ -3275,14 +3246,14 @@
       </p:sp>
       <p:sp>
         <p:nvSpPr>
-          <p:cNvPr id="7" name="TextBox 6"/>
+          <p:cNvPr id="6" name="TextBox 5"/>
           <p:cNvSpPr txBox="1"/>
           <p:nvPr/>
         </p:nvSpPr>
         <p:spPr>
           <a:xfrm>
-            <a:off x="540000" y="2880000"/>
-            <a:ext cx="4662000" cy="1800000"/>
+            <a:off x="540000" y="2952000"/>
+            <a:ext cx="4626000" cy="2160000"/>
           </a:xfrm>
           <a:prstGeom prst="rect">
             <a:avLst/>
@@ -3301,13 +3272,13 @@
               </a:spcAft>
             </a:pPr>
             <a:r>
-              <a:rPr sz="1600" b="0">
-                <a:solidFill>
-                  <a:srgbClr val="222222"/>
+              <a:rPr sz="1800" b="0">
+                <a:solidFill>
+                  <a:srgbClr val="000000"/>
                 </a:solidFill>
                 <a:latin typeface="Arial"/>
               </a:rPr>
-              <a:t>• eine schräge Rampe</a:t>
+              <a:t>• eine schräge Fläche, z. B. eine Rampe</a:t>
             </a:r>
           </a:p>
           <a:p>
@@ -3317,13 +3288,13 @@
               </a:spcAft>
             </a:pPr>
             <a:r>
-              <a:rPr sz="1600" b="0">
-                <a:solidFill>
-                  <a:srgbClr val="222222"/>
+              <a:rPr sz="1800" b="0">
+                <a:solidFill>
+                  <a:srgbClr val="000000"/>
                 </a:solidFill>
                 <a:latin typeface="Arial"/>
               </a:rPr>
-              <a:t>• ein Körper wird hochgezogen statt senkrecht gehoben</a:t>
+              <a:t>• man zieht einen Körper die Rampe hoch, statt ihn senkrecht hochzuheben</a:t>
             </a:r>
           </a:p>
           <a:p>
@@ -3333,13 +3304,13 @@
               </a:spcAft>
             </a:pPr>
             <a:r>
-              <a:rPr sz="1600" b="0">
-                <a:solidFill>
-                  <a:srgbClr val="222222"/>
+              <a:rPr sz="1800" b="0">
+                <a:solidFill>
+                  <a:srgbClr val="000000"/>
                 </a:solidFill>
                 <a:latin typeface="Arial"/>
               </a:rPr>
-              <a:t>• kraftumformende Einrichtung: man braucht weniger Kraft</a:t>
+              <a:t>• dafür braucht man weniger Kraft</a:t>
             </a:r>
           </a:p>
           <a:p>
@@ -3349,56 +3320,27 @@
               </a:spcAft>
             </a:pPr>
             <a:r>
-              <a:rPr sz="1600" b="0">
-                <a:solidFill>
-                  <a:srgbClr val="222222"/>
+              <a:rPr sz="1800" b="0">
+                <a:solidFill>
+                  <a:srgbClr val="000000"/>
                 </a:solidFill>
                 <a:latin typeface="Arial"/>
               </a:rPr>
-              <a:t>• Beispiel: Passstraße mit vielen Kurven</a:t>
-            </a:r>
-          </a:p>
-        </p:txBody>
-      </p:sp>
-      <p:sp>
-        <p:nvSpPr>
-          <p:cNvPr id="8" name="Rectangle 7"/>
-          <p:cNvSpPr/>
+              <a:t>• sie ist eine kraftumformende Einrichtung</a:t>
+            </a:r>
+          </a:p>
+        </p:txBody>
+      </p:sp>
+      <p:sp>
+        <p:nvSpPr>
+          <p:cNvPr id="7" name="TextBox 6"/>
+          <p:cNvSpPr txBox="1"/>
           <p:nvPr/>
         </p:nvSpPr>
         <p:spPr>
           <a:xfrm>
-            <a:off x="5490000" y="2376000"/>
-            <a:ext cx="4662000" cy="2592000"/>
-          </a:xfrm>
-          <a:prstGeom prst="rect">
-            <a:avLst/>
-          </a:prstGeom>
-          <a:solidFill>
-            <a:srgbClr val="EAF2FA"/>
-          </a:solidFill>
-          <a:ln>
-            <a:noFill/>
-          </a:ln>
-        </p:spPr>
-        <p:txBody>
-          <a:bodyPr rtlCol="0" anchor="ctr"/>
-          <a:lstStyle/>
-          <a:p>
-            <a:pPr algn="ctr"/>
-          </a:p>
-        </p:txBody>
-      </p:sp>
-      <p:sp>
-        <p:nvSpPr>
-          <p:cNvPr id="9" name="TextBox 8"/>
-          <p:cNvSpPr txBox="1"/>
-          <p:nvPr/>
-        </p:nvSpPr>
-        <p:spPr>
-          <a:xfrm>
-            <a:off x="5634000" y="2484000"/>
-            <a:ext cx="4374000" cy="432000"/>
+            <a:off x="5526000" y="2448000"/>
+            <a:ext cx="4626000" cy="432000"/>
           </a:xfrm>
           <a:prstGeom prst="rect">
             <a:avLst/>
@@ -3417,9 +3359,9 @@
               </a:spcAft>
             </a:pPr>
             <a:r>
-              <a:rPr sz="2600" b="1">
-                <a:solidFill>
-                  <a:srgbClr val="1F6FB2"/>
+              <a:rPr sz="2800" b="1">
+                <a:solidFill>
+                  <a:srgbClr val="000000"/>
                 </a:solidFill>
                 <a:latin typeface="Arial"/>
               </a:rPr>
@@ -3430,14 +3372,14 @@
       </p:sp>
       <p:sp>
         <p:nvSpPr>
-          <p:cNvPr id="10" name="TextBox 9"/>
+          <p:cNvPr id="8" name="TextBox 7"/>
           <p:cNvSpPr txBox="1"/>
           <p:nvPr/>
         </p:nvSpPr>
         <p:spPr>
           <a:xfrm>
-            <a:off x="5634000" y="2952000"/>
-            <a:ext cx="4374000" cy="648000"/>
+            <a:off x="5526000" y="2952000"/>
+            <a:ext cx="4626000" cy="2160000"/>
           </a:xfrm>
           <a:prstGeom prst="rect">
             <a:avLst/>
@@ -3456,38 +3398,15 @@
               </a:spcAft>
             </a:pPr>
             <a:r>
-              <a:rPr sz="1900" b="1">
-                <a:solidFill>
-                  <a:srgbClr val="222222"/>
+              <a:rPr sz="1800" b="1">
+                <a:solidFill>
+                  <a:srgbClr val="000000"/>
                 </a:solidFill>
                 <a:latin typeface="Arial"/>
               </a:rPr>
               <a:t>„Was man an Kraft spart, muss man mit Strecke bezahlen.“</a:t>
             </a:r>
           </a:p>
-        </p:txBody>
-      </p:sp>
-      <p:sp>
-        <p:nvSpPr>
-          <p:cNvPr id="11" name="TextBox 10"/>
-          <p:cNvSpPr txBox="1"/>
-          <p:nvPr/>
-        </p:nvSpPr>
-        <p:spPr>
-          <a:xfrm>
-            <a:off x="5634000" y="3672000"/>
-            <a:ext cx="4374000" cy="1296000"/>
-          </a:xfrm>
-          <a:prstGeom prst="rect">
-            <a:avLst/>
-          </a:prstGeom>
-          <a:noFill/>
-        </p:spPr>
-        <p:txBody>
-          <a:bodyPr wrap="square" anchor="t" lIns="36000" rIns="36000">
-            <a:spAutoFit/>
-          </a:bodyPr>
-          <a:lstStyle/>
           <a:p>
             <a:pPr algn="l">
               <a:spcAft>
@@ -3495,13 +3414,13 @@
               </a:spcAft>
             </a:pPr>
             <a:r>
-              <a:rPr sz="1600" b="0">
-                <a:solidFill>
-                  <a:srgbClr val="222222"/>
+              <a:rPr sz="1800" b="0">
+                <a:solidFill>
+                  <a:srgbClr val="000000"/>
                 </a:solidFill>
                 <a:latin typeface="Arial"/>
               </a:rPr>
-              <a:t>• lange Strecke → kleine Kraft</a:t>
+              <a:t>• je länger die Strecke, desto kleiner die Kraft</a:t>
             </a:r>
           </a:p>
           <a:p>
@@ -3511,13 +3430,13 @@
               </a:spcAft>
             </a:pPr>
             <a:r>
-              <a:rPr sz="1600" b="0">
-                <a:solidFill>
-                  <a:srgbClr val="222222"/>
+              <a:rPr sz="1800" b="0">
+                <a:solidFill>
+                  <a:srgbClr val="000000"/>
                 </a:solidFill>
                 <a:latin typeface="Arial"/>
               </a:rPr>
-              <a:t>• kurze Strecke → große Kraft</a:t>
+              <a:t>• die Arbeit W = F · s bleibt immer gleich</a:t>
             </a:r>
           </a:p>
           <a:p>
@@ -3527,36 +3446,20 @@
               </a:spcAft>
             </a:pPr>
             <a:r>
-              <a:rPr sz="1600" b="0">
-                <a:solidFill>
-                  <a:srgbClr val="222222"/>
+              <a:rPr sz="1800" b="0">
+                <a:solidFill>
+                  <a:srgbClr val="000000"/>
                 </a:solidFill>
                 <a:latin typeface="Arial"/>
               </a:rPr>
-              <a:t>• die Arbeit W = F · s bleibt gleich</a:t>
-            </a:r>
-          </a:p>
-          <a:p>
-            <a:pPr algn="l">
-              <a:spcAft>
-                <a:spcPts val="400"/>
-              </a:spcAft>
-            </a:pPr>
-            <a:r>
-              <a:rPr sz="1600" b="0">
-                <a:solidFill>
-                  <a:srgbClr val="222222"/>
-                </a:solidFill>
-                <a:latin typeface="Arial"/>
-              </a:rPr>
-              <a:t>• Energie spart man nicht!</a:t>
-            </a:r>
-          </a:p>
-        </p:txBody>
-      </p:sp>
-      <p:sp>
-        <p:nvSpPr>
-          <p:cNvPr id="12" name="TextBox 11"/>
+              <a:t>• Energie kann man so nicht sparen, nur Kraft</a:t>
+            </a:r>
+          </a:p>
+        </p:txBody>
+      </p:sp>
+      <p:sp>
+        <p:nvSpPr>
+          <p:cNvPr id="9" name="TextBox 8"/>
           <p:cNvSpPr txBox="1"/>
           <p:nvPr/>
         </p:nvSpPr>
@@ -3582,36 +3485,38 @@
               </a:spcAft>
             </a:pPr>
             <a:r>
-              <a:rPr sz="2600" b="1">
-                <a:solidFill>
-                  <a:srgbClr val="1F6FB2"/>
+              <a:rPr sz="2800" b="1">
+                <a:solidFill>
+                  <a:srgbClr val="000000"/>
                 </a:solidFill>
                 <a:latin typeface="Arial"/>
               </a:rPr>
-              <a:t>So funktioniert es</a:t>
-            </a:r>
-          </a:p>
-        </p:txBody>
-      </p:sp>
-      <p:sp>
-        <p:nvSpPr>
-          <p:cNvPr id="13" name="Right Triangle 12"/>
+              <a:t>Beispiel an der Rampe</a:t>
+            </a:r>
+          </a:p>
+        </p:txBody>
+      </p:sp>
+      <p:sp>
+        <p:nvSpPr>
+          <p:cNvPr id="10" name="Right Triangle 9"/>
           <p:cNvSpPr/>
           <p:nvPr/>
         </p:nvSpPr>
         <p:spPr>
           <a:xfrm flipH="1">
-            <a:off x="1260000" y="6048000"/>
+            <a:off x="1080000" y="6048000"/>
             <a:ext cx="4320000" cy="1620000"/>
           </a:xfrm>
           <a:prstGeom prst="rtTriangle">
             <a:avLst/>
           </a:prstGeom>
           <a:solidFill>
-            <a:srgbClr val="D9B98C"/>
+            <a:srgbClr val="DDDDDD"/>
           </a:solidFill>
-          <a:ln>
-            <a:noFill/>
+          <a:ln w="19050">
+            <a:solidFill>
+              <a:srgbClr val="000000"/>
+            </a:solidFill>
           </a:ln>
         </p:spPr>
         <p:txBody>
@@ -3624,23 +3529,25 @@
       </p:sp>
       <p:sp>
         <p:nvSpPr>
-          <p:cNvPr id="14" name="Rectangle 13"/>
+          <p:cNvPr id="11" name="Rectangle 10"/>
           <p:cNvSpPr/>
           <p:nvPr/>
         </p:nvSpPr>
         <p:spPr>
-          <a:xfrm>
-            <a:off x="1080000" y="7668000"/>
-            <a:ext cx="4860000" cy="72000"/>
+          <a:xfrm rot="20366637">
+            <a:off x="2643118" y="6643314"/>
+            <a:ext cx="648000" cy="288000"/>
           </a:xfrm>
           <a:prstGeom prst="rect">
             <a:avLst/>
           </a:prstGeom>
           <a:solidFill>
-            <a:srgbClr val="888888"/>
+            <a:srgbClr val="FFFFFF"/>
           </a:solidFill>
-          <a:ln>
-            <a:noFill/>
+          <a:ln w="19050">
+            <a:solidFill>
+              <a:srgbClr val="000000"/>
+            </a:solidFill>
           </a:ln>
         </p:spPr>
         <p:txBody>
@@ -3651,44 +3558,15 @@
           </a:p>
         </p:txBody>
       </p:sp>
-      <p:sp>
-        <p:nvSpPr>
-          <p:cNvPr id="15" name="Rounded Rectangle 14"/>
-          <p:cNvSpPr/>
-          <p:nvPr/>
-        </p:nvSpPr>
-        <p:spPr>
-          <a:xfrm rot="20366637">
-            <a:off x="2823118" y="6643314"/>
-            <a:ext cx="648000" cy="288000"/>
-          </a:xfrm>
-          <a:prstGeom prst="roundRect">
-            <a:avLst/>
-          </a:prstGeom>
-          <a:solidFill>
-            <a:srgbClr val="1F6FB2"/>
-          </a:solidFill>
-          <a:ln>
-            <a:noFill/>
-          </a:ln>
-        </p:spPr>
-        <p:txBody>
-          <a:bodyPr rtlCol="0" anchor="ctr"/>
-          <a:lstStyle/>
-          <a:p>
-            <a:pPr algn="ctr"/>
-          </a:p>
-        </p:txBody>
-      </p:sp>
       <p:cxnSp>
         <p:nvCxnSpPr>
-          <p:cNvPr id="16" name="Connector 15"/>
+          <p:cNvPr id="12" name="Connector 11"/>
           <p:cNvCxnSpPr/>
           <p:nvPr/>
         </p:nvCxnSpPr>
         <p:spPr>
           <a:xfrm flipV="1">
-            <a:off x="3484196" y="6382820"/>
+            <a:off x="3304196" y="6382820"/>
             <a:ext cx="741573" cy="278090"/>
           </a:xfrm>
           <a:prstGeom prst="line">
@@ -3696,9 +3574,9 @@
           </a:prstGeom>
           <a:ln w="38100">
             <a:solidFill>
-              <a:srgbClr val="C0392B"/>
+              <a:srgbClr val="D00000"/>
             </a:solidFill>
-            <a:tailEnd type="triangle" w="med" len="med"/>
+            <a:tailEnd type="triangle"/>
           </a:ln>
         </p:spPr>
         <p:style>
@@ -3718,13 +3596,13 @@
       </p:cxnSp>
       <p:sp>
         <p:nvSpPr>
-          <p:cNvPr id="17" name="TextBox 16"/>
+          <p:cNvPr id="13" name="TextBox 12"/>
           <p:cNvSpPr txBox="1"/>
           <p:nvPr/>
         </p:nvSpPr>
         <p:spPr>
           <a:xfrm>
-            <a:off x="3651118" y="5995314"/>
+            <a:off x="3471118" y="5995314"/>
             <a:ext cx="1080000" cy="288000"/>
           </a:xfrm>
           <a:prstGeom prst="rect">
@@ -3744,27 +3622,27 @@
               </a:spcAft>
             </a:pPr>
             <a:r>
-              <a:rPr sz="1600" b="1">
-                <a:solidFill>
-                  <a:srgbClr val="C0392B"/>
+              <a:rPr sz="2000" b="1">
+                <a:solidFill>
+                  <a:srgbClr val="D00000"/>
                 </a:solidFill>
                 <a:latin typeface="Arial"/>
               </a:rPr>
-              <a:t>Kraft F</a:t>
-            </a:r>
-          </a:p>
-        </p:txBody>
-      </p:sp>
-      <p:sp>
-        <p:nvSpPr>
-          <p:cNvPr id="18" name="TextBox 17"/>
+              <a:t>F</a:t>
+            </a:r>
+          </a:p>
+        </p:txBody>
+      </p:sp>
+      <p:sp>
+        <p:nvSpPr>
+          <p:cNvPr id="14" name="TextBox 13"/>
           <p:cNvSpPr txBox="1"/>
           <p:nvPr/>
         </p:nvSpPr>
         <p:spPr>
           <a:xfrm rot="20366637">
-            <a:off x="3636000" y="6939000"/>
-            <a:ext cx="1440000" cy="288000"/>
+            <a:off x="3456000" y="6939000"/>
+            <a:ext cx="720000" cy="288000"/>
           </a:xfrm>
           <a:prstGeom prst="rect">
             <a:avLst/>
@@ -3783,26 +3661,26 @@
               </a:spcAft>
             </a:pPr>
             <a:r>
-              <a:rPr sz="1600" b="1">
-                <a:solidFill>
-                  <a:srgbClr val="222222"/>
+              <a:rPr sz="2000" b="1">
+                <a:solidFill>
+                  <a:srgbClr val="000000"/>
                 </a:solidFill>
                 <a:latin typeface="Arial"/>
               </a:rPr>
-              <a:t>Strecke s</a:t>
+              <a:t>s</a:t>
             </a:r>
           </a:p>
         </p:txBody>
       </p:sp>
       <p:cxnSp>
         <p:nvCxnSpPr>
-          <p:cNvPr id="19" name="Connector 18"/>
+          <p:cNvPr id="15" name="Connector 14"/>
           <p:cNvCxnSpPr/>
           <p:nvPr/>
         </p:nvCxnSpPr>
         <p:spPr>
           <a:xfrm flipV="1">
-            <a:off x="5796000" y="6048000"/>
+            <a:off x="5616000" y="6048000"/>
             <a:ext cx="0" cy="1620000"/>
           </a:xfrm>
           <a:prstGeom prst="line">
@@ -3810,9 +3688,9 @@
           </a:prstGeom>
           <a:ln w="19050">
             <a:solidFill>
-              <a:srgbClr val="222222"/>
+              <a:srgbClr val="000000"/>
             </a:solidFill>
-            <a:tailEnd type="triangle" w="med" len="med"/>
+            <a:tailEnd type="triangle"/>
           </a:ln>
         </p:spPr>
         <p:style>
@@ -3832,13 +3710,13 @@
       </p:cxnSp>
       <p:sp>
         <p:nvSpPr>
-          <p:cNvPr id="20" name="TextBox 19"/>
+          <p:cNvPr id="16" name="TextBox 15"/>
           <p:cNvSpPr txBox="1"/>
           <p:nvPr/>
         </p:nvSpPr>
         <p:spPr>
           <a:xfrm>
-            <a:off x="5868000" y="6714000"/>
+            <a:off x="5688000" y="6714000"/>
             <a:ext cx="1080000" cy="288000"/>
           </a:xfrm>
           <a:prstGeom prst="rect">
@@ -3858,27 +3736,27 @@
               </a:spcAft>
             </a:pPr>
             <a:r>
-              <a:rPr sz="1600" b="1">
-                <a:solidFill>
-                  <a:srgbClr val="222222"/>
+              <a:rPr sz="1800" b="0">
+                <a:solidFill>
+                  <a:srgbClr val="000000"/>
                 </a:solidFill>
                 <a:latin typeface="Arial"/>
               </a:rPr>
-              <a:t>Höhe h</a:t>
-            </a:r>
-          </a:p>
-        </p:txBody>
-      </p:sp>
-      <p:sp>
-        <p:nvSpPr>
-          <p:cNvPr id="21" name="TextBox 20"/>
+              <a:t>h = 1 m</a:t>
+            </a:r>
+          </a:p>
+        </p:txBody>
+      </p:sp>
+      <p:sp>
+        <p:nvSpPr>
+          <p:cNvPr id="17" name="TextBox 16"/>
           <p:cNvSpPr txBox="1"/>
           <p:nvPr/>
         </p:nvSpPr>
         <p:spPr>
           <a:xfrm>
-            <a:off x="7020000" y="5832000"/>
-            <a:ext cx="3132000" cy="1980000"/>
+            <a:off x="6840000" y="5832000"/>
+            <a:ext cx="3312000" cy="2160000"/>
           </a:xfrm>
           <a:prstGeom prst="rect">
             <a:avLst/>
@@ -3897,13 +3775,29 @@
               </a:spcAft>
             </a:pPr>
             <a:r>
-              <a:rPr sz="1600" b="1">
-                <a:solidFill>
-                  <a:srgbClr val="222222"/>
+              <a:rPr sz="1800" b="0">
+                <a:solidFill>
+                  <a:srgbClr val="000000"/>
                 </a:solidFill>
                 <a:latin typeface="Arial"/>
               </a:rPr>
-              <a:t>Rechenbeispiel:</a:t>
+              <a:t>Ein Wagen (1 kg) wird 1 m hoch gebracht.</a:t>
+            </a:r>
+          </a:p>
+          <a:p>
+            <a:pPr algn="l">
+              <a:spcAft>
+                <a:spcPts val="0"/>
+              </a:spcAft>
+            </a:pPr>
+            <a:r>
+              <a:rPr sz="1800" b="1">
+                <a:solidFill>
+                  <a:srgbClr val="000000"/>
+                </a:solidFill>
+                <a:latin typeface="Arial"/>
+              </a:rPr>
+              <a:t>Senkrecht hochheben:</a:t>
             </a:r>
           </a:p>
           <a:p>
@@ -3913,13 +3807,13 @@
               </a:spcAft>
             </a:pPr>
             <a:r>
-              <a:rPr sz="1600" b="0">
-                <a:solidFill>
-                  <a:srgbClr val="222222"/>
+              <a:rPr sz="1800" b="0">
+                <a:solidFill>
+                  <a:srgbClr val="000000"/>
                 </a:solidFill>
                 <a:latin typeface="Arial"/>
               </a:rPr>
-              <a:t>Wagen (1,0 kg) auf 1,0 m Höhe</a:t>
+              <a:t>W = 9,8 N · 1,0 m = 9,8 J</a:t>
             </a:r>
           </a:p>
           <a:p>
@@ -3929,13 +3823,13 @@
               </a:spcAft>
             </a:pPr>
             <a:r>
-              <a:rPr sz="1600" b="1">
-                <a:solidFill>
-                  <a:srgbClr val="222222"/>
+              <a:rPr sz="1800" b="1">
+                <a:solidFill>
+                  <a:srgbClr val="000000"/>
                 </a:solidFill>
                 <a:latin typeface="Arial"/>
               </a:rPr>
-              <a:t>direkt hoch:</a:t>
+              <a:t>Über die Rampe:</a:t>
             </a:r>
           </a:p>
           <a:p>
@@ -3945,29 +3839,13 @@
               </a:spcAft>
             </a:pPr>
             <a:r>
-              <a:rPr sz="1600" b="0">
-                <a:solidFill>
-                  <a:srgbClr val="222222"/>
+              <a:rPr sz="1800" b="0">
+                <a:solidFill>
+                  <a:srgbClr val="000000"/>
                 </a:solidFill>
                 <a:latin typeface="Arial"/>
               </a:rPr>
-              <a:t>9,8 N · 1,0 m = 9,8 J</a:t>
-            </a:r>
-          </a:p>
-          <a:p>
-            <a:pPr algn="l">
-              <a:spcAft>
-                <a:spcPts val="0"/>
-              </a:spcAft>
-            </a:pPr>
-            <a:r>
-              <a:rPr sz="1600" b="1">
-                <a:solidFill>
-                  <a:srgbClr val="222222"/>
-                </a:solidFill>
-                <a:latin typeface="Arial"/>
-              </a:rPr>
-              <a:t>über die Rampe:</a:t>
+              <a:t>W = 4,1 N · 2,4 m = 9,8 J</a:t>
             </a:r>
           </a:p>
           <a:p>
@@ -3977,71 +3855,26 @@
               </a:spcAft>
             </a:pPr>
             <a:r>
-              <a:rPr sz="1600" b="0">
-                <a:solidFill>
-                  <a:srgbClr val="222222"/>
+              <a:rPr sz="1800" b="0">
+                <a:solidFill>
+                  <a:srgbClr val="000000"/>
                 </a:solidFill>
                 <a:latin typeface="Arial"/>
               </a:rPr>
-              <a:t>4,1 N · 2,4 m ≈ 9,8 J</a:t>
-            </a:r>
-          </a:p>
-          <a:p>
-            <a:pPr algn="l">
-              <a:spcAft>
-                <a:spcPts val="400"/>
-              </a:spcAft>
-            </a:pPr>
-            <a:r>
-              <a:rPr sz="1600" b="1">
-                <a:solidFill>
-                  <a:srgbClr val="1F6FB2"/>
-                </a:solidFill>
-                <a:latin typeface="Arial"/>
-              </a:rPr>
-              <a:t>→ gleiche Arbeit!</a:t>
-            </a:r>
-          </a:p>
-        </p:txBody>
-      </p:sp>
-      <p:sp>
-        <p:nvSpPr>
-          <p:cNvPr id="22" name="Rectangle 21"/>
-          <p:cNvSpPr/>
+              <a:t>Beide Male ist die Arbeit gleich.</a:t>
+            </a:r>
+          </a:p>
+        </p:txBody>
+      </p:sp>
+      <p:sp>
+        <p:nvSpPr>
+          <p:cNvPr id="18" name="TextBox 17"/>
+          <p:cNvSpPr txBox="1"/>
           <p:nvPr/>
         </p:nvSpPr>
         <p:spPr>
           <a:xfrm>
-            <a:off x="540000" y="7992000"/>
-            <a:ext cx="9612000" cy="43200"/>
-          </a:xfrm>
-          <a:prstGeom prst="rect">
-            <a:avLst/>
-          </a:prstGeom>
-          <a:solidFill>
-            <a:srgbClr val="1F6FB2"/>
-          </a:solidFill>
-          <a:ln>
-            <a:noFill/>
-          </a:ln>
-        </p:spPr>
-        <p:txBody>
-          <a:bodyPr rtlCol="0" anchor="ctr"/>
-          <a:lstStyle/>
-          <a:p>
-            <a:pPr algn="ctr"/>
-          </a:p>
-        </p:txBody>
-      </p:sp>
-      <p:sp>
-        <p:nvSpPr>
-          <p:cNvPr id="23" name="TextBox 22"/>
-          <p:cNvSpPr txBox="1"/>
-          <p:nvPr/>
-        </p:nvSpPr>
-        <p:spPr>
-          <a:xfrm>
-            <a:off x="540000" y="8172000"/>
+            <a:off x="540000" y="8064000"/>
             <a:ext cx="9612000" cy="432000"/>
           </a:xfrm>
           <a:prstGeom prst="rect">
@@ -4061,27 +3894,27 @@
               </a:spcAft>
             </a:pPr>
             <a:r>
-              <a:rPr sz="2600" b="1">
-                <a:solidFill>
-                  <a:srgbClr val="1F6FB2"/>
+              <a:rPr sz="2800" b="1">
+                <a:solidFill>
+                  <a:srgbClr val="000000"/>
                 </a:solidFill>
                 <a:latin typeface="Arial"/>
               </a:rPr>
-              <a:t>Experiment: Rampen im Vergleich</a:t>
-            </a:r>
-          </a:p>
-        </p:txBody>
-      </p:sp>
-      <p:sp>
-        <p:nvSpPr>
-          <p:cNvPr id="24" name="TextBox 23"/>
+              <a:t>Experiment</a:t>
+            </a:r>
+          </a:p>
+        </p:txBody>
+      </p:sp>
+      <p:sp>
+        <p:nvSpPr>
+          <p:cNvPr id="19" name="TextBox 18"/>
           <p:cNvSpPr txBox="1"/>
           <p:nvPr/>
         </p:nvSpPr>
         <p:spPr>
           <a:xfrm>
-            <a:off x="540000" y="8676000"/>
-            <a:ext cx="4320000" cy="2880000"/>
+            <a:off x="540000" y="8568000"/>
+            <a:ext cx="4500000" cy="2880000"/>
           </a:xfrm>
           <a:prstGeom prst="rect">
             <a:avLst/>
@@ -4096,17 +3929,17 @@
           <a:p>
             <a:pPr algn="l">
               <a:spcAft>
-                <a:spcPts val="400"/>
+                <a:spcPts val="0"/>
               </a:spcAft>
             </a:pPr>
             <a:r>
-              <a:rPr sz="1600" b="1">
-                <a:solidFill>
-                  <a:srgbClr val="222222"/>
+              <a:rPr sz="1800" b="1">
+                <a:solidFill>
+                  <a:srgbClr val="000000"/>
                 </a:solidFill>
                 <a:latin typeface="Arial"/>
               </a:rPr>
-              <a:t>Aufbau</a:t>
+              <a:t>Material:</a:t>
             </a:r>
           </a:p>
           <a:p>
@@ -4116,13 +3949,29 @@
               </a:spcAft>
             </a:pPr>
             <a:r>
-              <a:rPr sz="1600" b="0">
-                <a:solidFill>
-                  <a:srgbClr val="222222"/>
+              <a:rPr sz="1800" b="0">
+                <a:solidFill>
+                  <a:srgbClr val="000000"/>
                 </a:solidFill>
                 <a:latin typeface="Arial"/>
               </a:rPr>
-              <a:t>• Wagen (1,0 kg), Rampe, Kraftmesser</a:t>
+              <a:t>Wagen (1 kg), Rampe, Kraftmesser</a:t>
+            </a:r>
+          </a:p>
+          <a:p>
+            <a:pPr algn="l">
+              <a:spcAft>
+                <a:spcPts val="0"/>
+              </a:spcAft>
+            </a:pPr>
+            <a:r>
+              <a:rPr sz="1800" b="1">
+                <a:solidFill>
+                  <a:srgbClr val="000000"/>
+                </a:solidFill>
+                <a:latin typeface="Arial"/>
+              </a:rPr>
+              <a:t>Aufbau:</a:t>
             </a:r>
           </a:p>
           <a:p>
@@ -4132,13 +3981,29 @@
               </a:spcAft>
             </a:pPr>
             <a:r>
-              <a:rPr sz="1600" b="0">
-                <a:solidFill>
-                  <a:srgbClr val="222222"/>
+              <a:rPr sz="1800" b="0">
+                <a:solidFill>
+                  <a:srgbClr val="000000"/>
                 </a:solidFill>
                 <a:latin typeface="Arial"/>
               </a:rPr>
-              <a:t>• Rampe endet immer in 1,0 m Höhe</a:t>
+              <a:t>Die Rampe endet immer in 1 m Höhe.</a:t>
+            </a:r>
+          </a:p>
+          <a:p>
+            <a:pPr algn="l">
+              <a:spcAft>
+                <a:spcPts val="0"/>
+              </a:spcAft>
+            </a:pPr>
+            <a:r>
+              <a:rPr sz="1800" b="1">
+                <a:solidFill>
+                  <a:srgbClr val="000000"/>
+                </a:solidFill>
+                <a:latin typeface="Arial"/>
+              </a:rPr>
+              <a:t>Durchführung:</a:t>
             </a:r>
           </a:p>
           <a:p>
@@ -4148,103 +4013,39 @@
               </a:spcAft>
             </a:pPr>
             <a:r>
-              <a:rPr sz="1600" b="1">
-                <a:solidFill>
-                  <a:srgbClr val="222222"/>
+              <a:rPr sz="1800" b="0">
+                <a:solidFill>
+                  <a:srgbClr val="000000"/>
                 </a:solidFill>
                 <a:latin typeface="Arial"/>
               </a:rPr>
-              <a:t>Durchführung</a:t>
-            </a:r>
-          </a:p>
-          <a:p>
-            <a:pPr algn="l">
-              <a:spcAft>
-                <a:spcPts val="400"/>
-              </a:spcAft>
-            </a:pPr>
-            <a:r>
-              <a:rPr sz="1600" b="0">
-                <a:solidFill>
-                  <a:srgbClr val="222222"/>
-                </a:solidFill>
-                <a:latin typeface="Arial"/>
-              </a:rPr>
-              <a:t>• Wagen langsam die Rampe hochziehen</a:t>
-            </a:r>
-          </a:p>
-          <a:p>
-            <a:pPr algn="l">
-              <a:spcAft>
-                <a:spcPts val="400"/>
-              </a:spcAft>
-            </a:pPr>
-            <a:r>
-              <a:rPr sz="1600" b="0">
-                <a:solidFill>
-                  <a:srgbClr val="222222"/>
-                </a:solidFill>
-                <a:latin typeface="Arial"/>
-              </a:rPr>
-              <a:t>• Kraft F ablesen, Strecke s messen</a:t>
-            </a:r>
-          </a:p>
-          <a:p>
-            <a:pPr algn="l">
-              <a:spcAft>
-                <a:spcPts val="400"/>
-              </a:spcAft>
-            </a:pPr>
-            <a:r>
-              <a:rPr sz="1600" b="0">
-                <a:solidFill>
-                  <a:srgbClr val="222222"/>
-                </a:solidFill>
-                <a:latin typeface="Arial"/>
-              </a:rPr>
-              <a:t>• mit verschieden steilen Rampen wiederholen</a:t>
-            </a:r>
-          </a:p>
-          <a:p>
-            <a:pPr algn="l">
-              <a:spcAft>
-                <a:spcPts val="400"/>
-              </a:spcAft>
-            </a:pPr>
-            <a:r>
-              <a:rPr sz="1600" b="0">
-                <a:solidFill>
-                  <a:srgbClr val="222222"/>
-                </a:solidFill>
-                <a:latin typeface="Arial"/>
-              </a:rPr>
-              <a:t>• jedes Mal F · s ausrechnen</a:t>
+              <a:t>Wir ziehen den Wagen langsam die Rampe hoch und lesen die Kraft F ab. Die Strecke s messen wir. Das machen wir mit verschieden steilen Rampen und rechnen jedes Mal F · s aus.</a:t>
             </a:r>
           </a:p>
         </p:txBody>
       </p:sp>
       <p:graphicFrame>
         <p:nvGraphicFramePr>
-          <p:cNvPr id="25" name="Table 24"/>
+          <p:cNvPr id="20" name="Table 19"/>
           <p:cNvGraphicFramePr>
             <a:graphicFrameLocks noGrp="1"/>
           </p:cNvGraphicFramePr>
           <p:nvPr/>
         </p:nvGraphicFramePr>
         <p:xfrm>
-          <a:off x="5220000" y="8712000"/>
-          <a:ext cx="4932000" cy="1944000"/>
+          <a:off x="5472000" y="8640000"/>
+          <a:ext cx="4680000" cy="1944000"/>
         </p:xfrm>
         <a:graphic>
           <a:graphicData uri="http://schemas.openxmlformats.org/drawingml/2006/table">
             <a:tbl>
-              <a:tblPr firstRow="1" bandRow="1">
+              <a:tblPr>
                 <a:tableStyleId>{5C22544A-7EE6-4342-B048-85BDC9FD1C3A}</a:tableStyleId>
               </a:tblPr>
               <a:tblGrid>
-                <a:gridCol w="1644000"/>
-                <a:gridCol w="1644000"/>
-                <a:gridCol w="1644000"/>
+                <a:gridCol w="1560000"/>
+                <a:gridCol w="1560000"/>
+                <a:gridCol w="1560000"/>
               </a:tblGrid>
               <a:tr h="324000">
                 <a:tc>
@@ -4254,9 +4055,9 @@
                     <a:p>
                       <a:pPr algn="ctr"/>
                       <a:r>
-                        <a:rPr sz="1500" b="1">
+                        <a:rPr sz="1600" b="1">
                           <a:solidFill>
-                            <a:srgbClr val="FFFFFF"/>
+                            <a:srgbClr val="000000"/>
                           </a:solidFill>
                           <a:latin typeface="Arial"/>
                         </a:rPr>
@@ -4266,8 +4067,28 @@
                   </a:txBody>
                   <a:tcPr>
                     <a:solidFill>
-                      <a:srgbClr val="1F6FB2"/>
+                      <a:srgbClr val="FFFFFF"/>
                     </a:solidFill>
+                    <a:lnL w="12700">
+                      <a:solidFill>
+                        <a:srgbClr val="000000"/>
+                      </a:solidFill>
+                    </a:lnL>
+                    <a:lnR w="12700">
+                      <a:solidFill>
+                        <a:srgbClr val="000000"/>
+                      </a:solidFill>
+                    </a:lnR>
+                    <a:lnT w="12700">
+                      <a:solidFill>
+                        <a:srgbClr val="000000"/>
+                      </a:solidFill>
+                    </a:lnT>
+                    <a:lnB w="12700">
+                      <a:solidFill>
+                        <a:srgbClr val="000000"/>
+                      </a:solidFill>
+                    </a:lnB>
                   </a:tcPr>
                 </a:tc>
                 <a:tc>
@@ -4277,9 +4098,9 @@
                     <a:p>
                       <a:pPr algn="ctr"/>
                       <a:r>
-                        <a:rPr sz="1500" b="1">
+                        <a:rPr sz="1600" b="1">
                           <a:solidFill>
-                            <a:srgbClr val="FFFFFF"/>
+                            <a:srgbClr val="000000"/>
                           </a:solidFill>
                           <a:latin typeface="Arial"/>
                         </a:rPr>
@@ -4289,8 +4110,28 @@
                   </a:txBody>
                   <a:tcPr>
                     <a:solidFill>
-                      <a:srgbClr val="1F6FB2"/>
+                      <a:srgbClr val="FFFFFF"/>
                     </a:solidFill>
+                    <a:lnL w="12700">
+                      <a:solidFill>
+                        <a:srgbClr val="000000"/>
+                      </a:solidFill>
+                    </a:lnL>
+                    <a:lnR w="12700">
+                      <a:solidFill>
+                        <a:srgbClr val="000000"/>
+                      </a:solidFill>
+                    </a:lnR>
+                    <a:lnT w="12700">
+                      <a:solidFill>
+                        <a:srgbClr val="000000"/>
+                      </a:solidFill>
+                    </a:lnT>
+                    <a:lnB w="12700">
+                      <a:solidFill>
+                        <a:srgbClr val="000000"/>
+                      </a:solidFill>
+                    </a:lnB>
                   </a:tcPr>
                 </a:tc>
                 <a:tc>
@@ -4300,9 +4141,9 @@
                     <a:p>
                       <a:pPr algn="ctr"/>
                       <a:r>
-                        <a:rPr sz="1500" b="1">
+                        <a:rPr sz="1600" b="1">
                           <a:solidFill>
-                            <a:srgbClr val="FFFFFF"/>
+                            <a:srgbClr val="000000"/>
                           </a:solidFill>
                           <a:latin typeface="Arial"/>
                         </a:rPr>
@@ -4312,8 +4153,28 @@
                   </a:txBody>
                   <a:tcPr>
                     <a:solidFill>
-                      <a:srgbClr val="1F6FB2"/>
+                      <a:srgbClr val="FFFFFF"/>
                     </a:solidFill>
+                    <a:lnL w="12700">
+                      <a:solidFill>
+                        <a:srgbClr val="000000"/>
+                      </a:solidFill>
+                    </a:lnL>
+                    <a:lnR w="12700">
+                      <a:solidFill>
+                        <a:srgbClr val="000000"/>
+                      </a:solidFill>
+                    </a:lnR>
+                    <a:lnT w="12700">
+                      <a:solidFill>
+                        <a:srgbClr val="000000"/>
+                      </a:solidFill>
+                    </a:lnT>
+                    <a:lnB w="12700">
+                      <a:solidFill>
+                        <a:srgbClr val="000000"/>
+                      </a:solidFill>
+                    </a:lnB>
                   </a:tcPr>
                 </a:tc>
               </a:tr>
@@ -4325,9 +4186,9 @@
                     <a:p>
                       <a:pPr algn="ctr"/>
                       <a:r>
-                        <a:rPr sz="1500" b="0">
+                        <a:rPr sz="1600" b="0">
                           <a:solidFill>
-                            <a:srgbClr val="222222"/>
+                            <a:srgbClr val="000000"/>
                           </a:solidFill>
                           <a:latin typeface="Arial"/>
                         </a:rPr>
@@ -4337,8 +4198,28 @@
                   </a:txBody>
                   <a:tcPr>
                     <a:solidFill>
-                      <a:srgbClr val="EAF2FA"/>
+                      <a:srgbClr val="FFFFFF"/>
                     </a:solidFill>
+                    <a:lnL w="12700">
+                      <a:solidFill>
+                        <a:srgbClr val="000000"/>
+                      </a:solidFill>
+                    </a:lnL>
+                    <a:lnR w="12700">
+                      <a:solidFill>
+                        <a:srgbClr val="000000"/>
+                      </a:solidFill>
+                    </a:lnR>
+                    <a:lnT w="12700">
+                      <a:solidFill>
+                        <a:srgbClr val="000000"/>
+                      </a:solidFill>
+                    </a:lnT>
+                    <a:lnB w="12700">
+                      <a:solidFill>
+                        <a:srgbClr val="000000"/>
+                      </a:solidFill>
+                    </a:lnB>
                   </a:tcPr>
                 </a:tc>
                 <a:tc>
@@ -4348,9 +4229,9 @@
                     <a:p>
                       <a:pPr algn="ctr"/>
                       <a:r>
-                        <a:rPr sz="1500" b="0">
+                        <a:rPr sz="1600" b="0">
                           <a:solidFill>
-                            <a:srgbClr val="222222"/>
+                            <a:srgbClr val="000000"/>
                           </a:solidFill>
                           <a:latin typeface="Arial"/>
                         </a:rPr>
@@ -4360,8 +4241,28 @@
                   </a:txBody>
                   <a:tcPr>
                     <a:solidFill>
-                      <a:srgbClr val="EAF2FA"/>
+                      <a:srgbClr val="FFFFFF"/>
                     </a:solidFill>
+                    <a:lnL w="12700">
+                      <a:solidFill>
+                        <a:srgbClr val="000000"/>
+                      </a:solidFill>
+                    </a:lnL>
+                    <a:lnR w="12700">
+                      <a:solidFill>
+                        <a:srgbClr val="000000"/>
+                      </a:solidFill>
+                    </a:lnR>
+                    <a:lnT w="12700">
+                      <a:solidFill>
+                        <a:srgbClr val="000000"/>
+                      </a:solidFill>
+                    </a:lnT>
+                    <a:lnB w="12700">
+                      <a:solidFill>
+                        <a:srgbClr val="000000"/>
+                      </a:solidFill>
+                    </a:lnB>
                   </a:tcPr>
                 </a:tc>
                 <a:tc>
@@ -4371,9 +4272,9 @@
                     <a:p>
                       <a:pPr algn="ctr"/>
                       <a:r>
-                        <a:rPr sz="1500" b="0">
+                        <a:rPr sz="1600" b="0">
                           <a:solidFill>
-                            <a:srgbClr val="222222"/>
+                            <a:srgbClr val="000000"/>
                           </a:solidFill>
                           <a:latin typeface="Arial"/>
                         </a:rPr>
@@ -4383,8 +4284,28 @@
                   </a:txBody>
                   <a:tcPr>
                     <a:solidFill>
-                      <a:srgbClr val="EAF2FA"/>
+                      <a:srgbClr val="FFFFFF"/>
                     </a:solidFill>
+                    <a:lnL w="12700">
+                      <a:solidFill>
+                        <a:srgbClr val="000000"/>
+                      </a:solidFill>
+                    </a:lnL>
+                    <a:lnR w="12700">
+                      <a:solidFill>
+                        <a:srgbClr val="000000"/>
+                      </a:solidFill>
+                    </a:lnR>
+                    <a:lnT w="12700">
+                      <a:solidFill>
+                        <a:srgbClr val="000000"/>
+                      </a:solidFill>
+                    </a:lnT>
+                    <a:lnB w="12700">
+                      <a:solidFill>
+                        <a:srgbClr val="000000"/>
+                      </a:solidFill>
+                    </a:lnB>
                   </a:tcPr>
                 </a:tc>
               </a:tr>
@@ -4396,9 +4317,9 @@
                     <a:p>
                       <a:pPr algn="ctr"/>
                       <a:r>
-                        <a:rPr sz="1500" b="0">
+                        <a:rPr sz="1600" b="0">
                           <a:solidFill>
-                            <a:srgbClr val="222222"/>
+                            <a:srgbClr val="000000"/>
                           </a:solidFill>
                           <a:latin typeface="Arial"/>
                         </a:rPr>
@@ -4410,6 +4331,26 @@
                     <a:solidFill>
                       <a:srgbClr val="FFFFFF"/>
                     </a:solidFill>
+                    <a:lnL w="12700">
+                      <a:solidFill>
+                        <a:srgbClr val="000000"/>
+                      </a:solidFill>
+                    </a:lnL>
+                    <a:lnR w="12700">
+                      <a:solidFill>
+                        <a:srgbClr val="000000"/>
+                      </a:solidFill>
+                    </a:lnR>
+                    <a:lnT w="12700">
+                      <a:solidFill>
+                        <a:srgbClr val="000000"/>
+                      </a:solidFill>
+                    </a:lnT>
+                    <a:lnB w="12700">
+                      <a:solidFill>
+                        <a:srgbClr val="000000"/>
+                      </a:solidFill>
+                    </a:lnB>
                   </a:tcPr>
                 </a:tc>
                 <a:tc>
@@ -4419,9 +4360,9 @@
                     <a:p>
                       <a:pPr algn="ctr"/>
                       <a:r>
-                        <a:rPr sz="1500" b="0">
+                        <a:rPr sz="1600" b="0">
                           <a:solidFill>
-                            <a:srgbClr val="222222"/>
+                            <a:srgbClr val="000000"/>
                           </a:solidFill>
                           <a:latin typeface="Arial"/>
                         </a:rPr>
@@ -4433,6 +4374,26 @@
                     <a:solidFill>
                       <a:srgbClr val="FFFFFF"/>
                     </a:solidFill>
+                    <a:lnL w="12700">
+                      <a:solidFill>
+                        <a:srgbClr val="000000"/>
+                      </a:solidFill>
+                    </a:lnL>
+                    <a:lnR w="12700">
+                      <a:solidFill>
+                        <a:srgbClr val="000000"/>
+                      </a:solidFill>
+                    </a:lnR>
+                    <a:lnT w="12700">
+                      <a:solidFill>
+                        <a:srgbClr val="000000"/>
+                      </a:solidFill>
+                    </a:lnT>
+                    <a:lnB w="12700">
+                      <a:solidFill>
+                        <a:srgbClr val="000000"/>
+                      </a:solidFill>
+                    </a:lnB>
                   </a:tcPr>
                 </a:tc>
                 <a:tc>
@@ -4442,9 +4403,9 @@
                     <a:p>
                       <a:pPr algn="ctr"/>
                       <a:r>
-                        <a:rPr sz="1500" b="0">
+                        <a:rPr sz="1600" b="0">
                           <a:solidFill>
-                            <a:srgbClr val="222222"/>
+                            <a:srgbClr val="000000"/>
                           </a:solidFill>
                           <a:latin typeface="Arial"/>
                         </a:rPr>
@@ -4456,6 +4417,26 @@
                     <a:solidFill>
                       <a:srgbClr val="FFFFFF"/>
                     </a:solidFill>
+                    <a:lnL w="12700">
+                      <a:solidFill>
+                        <a:srgbClr val="000000"/>
+                      </a:solidFill>
+                    </a:lnL>
+                    <a:lnR w="12700">
+                      <a:solidFill>
+                        <a:srgbClr val="000000"/>
+                      </a:solidFill>
+                    </a:lnR>
+                    <a:lnT w="12700">
+                      <a:solidFill>
+                        <a:srgbClr val="000000"/>
+                      </a:solidFill>
+                    </a:lnT>
+                    <a:lnB w="12700">
+                      <a:solidFill>
+                        <a:srgbClr val="000000"/>
+                      </a:solidFill>
+                    </a:lnB>
                   </a:tcPr>
                 </a:tc>
               </a:tr>
@@ -4467,9 +4448,9 @@
                     <a:p>
                       <a:pPr algn="ctr"/>
                       <a:r>
-                        <a:rPr sz="1500" b="0">
+                        <a:rPr sz="1600" b="0">
                           <a:solidFill>
-                            <a:srgbClr val="222222"/>
+                            <a:srgbClr val="000000"/>
                           </a:solidFill>
                           <a:latin typeface="Arial"/>
                         </a:rPr>
@@ -4479,8 +4460,28 @@
                   </a:txBody>
                   <a:tcPr>
                     <a:solidFill>
-                      <a:srgbClr val="EAF2FA"/>
+                      <a:srgbClr val="FFFFFF"/>
                     </a:solidFill>
+                    <a:lnL w="12700">
+                      <a:solidFill>
+                        <a:srgbClr val="000000"/>
+                      </a:solidFill>
+                    </a:lnL>
+                    <a:lnR w="12700">
+                      <a:solidFill>
+                        <a:srgbClr val="000000"/>
+                      </a:solidFill>
+                    </a:lnR>
+                    <a:lnT w="12700">
+                      <a:solidFill>
+                        <a:srgbClr val="000000"/>
+                      </a:solidFill>
+                    </a:lnT>
+                    <a:lnB w="12700">
+                      <a:solidFill>
+                        <a:srgbClr val="000000"/>
+                      </a:solidFill>
+                    </a:lnB>
                   </a:tcPr>
                 </a:tc>
                 <a:tc>
@@ -4490,9 +4491,9 @@
                     <a:p>
                       <a:pPr algn="ctr"/>
                       <a:r>
-                        <a:rPr sz="1500" b="0">
+                        <a:rPr sz="1600" b="0">
                           <a:solidFill>
-                            <a:srgbClr val="222222"/>
+                            <a:srgbClr val="000000"/>
                           </a:solidFill>
                           <a:latin typeface="Arial"/>
                         </a:rPr>
@@ -4502,8 +4503,28 @@
                   </a:txBody>
                   <a:tcPr>
                     <a:solidFill>
-                      <a:srgbClr val="EAF2FA"/>
+                      <a:srgbClr val="FFFFFF"/>
                     </a:solidFill>
+                    <a:lnL w="12700">
+                      <a:solidFill>
+                        <a:srgbClr val="000000"/>
+                      </a:solidFill>
+                    </a:lnL>
+                    <a:lnR w="12700">
+                      <a:solidFill>
+                        <a:srgbClr val="000000"/>
+                      </a:solidFill>
+                    </a:lnR>
+                    <a:lnT w="12700">
+                      <a:solidFill>
+                        <a:srgbClr val="000000"/>
+                      </a:solidFill>
+                    </a:lnT>
+                    <a:lnB w="12700">
+                      <a:solidFill>
+                        <a:srgbClr val="000000"/>
+                      </a:solidFill>
+                    </a:lnB>
                   </a:tcPr>
                 </a:tc>
                 <a:tc>
@@ -4513,9 +4534,9 @@
                     <a:p>
                       <a:pPr algn="ctr"/>
                       <a:r>
-                        <a:rPr sz="1500" b="0">
+                        <a:rPr sz="1600" b="0">
                           <a:solidFill>
-                            <a:srgbClr val="222222"/>
+                            <a:srgbClr val="000000"/>
                           </a:solidFill>
                           <a:latin typeface="Arial"/>
                         </a:rPr>
@@ -4525,8 +4546,28 @@
                   </a:txBody>
                   <a:tcPr>
                     <a:solidFill>
-                      <a:srgbClr val="EAF2FA"/>
+                      <a:srgbClr val="FFFFFF"/>
                     </a:solidFill>
+                    <a:lnL w="12700">
+                      <a:solidFill>
+                        <a:srgbClr val="000000"/>
+                      </a:solidFill>
+                    </a:lnL>
+                    <a:lnR w="12700">
+                      <a:solidFill>
+                        <a:srgbClr val="000000"/>
+                      </a:solidFill>
+                    </a:lnR>
+                    <a:lnT w="12700">
+                      <a:solidFill>
+                        <a:srgbClr val="000000"/>
+                      </a:solidFill>
+                    </a:lnT>
+                    <a:lnB w="12700">
+                      <a:solidFill>
+                        <a:srgbClr val="000000"/>
+                      </a:solidFill>
+                    </a:lnB>
                   </a:tcPr>
                 </a:tc>
               </a:tr>
@@ -4538,9 +4579,9 @@
                     <a:p>
                       <a:pPr algn="ctr"/>
                       <a:r>
-                        <a:rPr sz="1500" b="0">
+                        <a:rPr sz="1600" b="0">
                           <a:solidFill>
-                            <a:srgbClr val="222222"/>
+                            <a:srgbClr val="000000"/>
                           </a:solidFill>
                           <a:latin typeface="Arial"/>
                         </a:rPr>
@@ -4552,6 +4593,26 @@
                     <a:solidFill>
                       <a:srgbClr val="FFFFFF"/>
                     </a:solidFill>
+                    <a:lnL w="12700">
+                      <a:solidFill>
+                        <a:srgbClr val="000000"/>
+                      </a:solidFill>
+                    </a:lnL>
+                    <a:lnR w="12700">
+                      <a:solidFill>
+                        <a:srgbClr val="000000"/>
+                      </a:solidFill>
+                    </a:lnR>
+                    <a:lnT w="12700">
+                      <a:solidFill>
+                        <a:srgbClr val="000000"/>
+                      </a:solidFill>
+                    </a:lnT>
+                    <a:lnB w="12700">
+                      <a:solidFill>
+                        <a:srgbClr val="000000"/>
+                      </a:solidFill>
+                    </a:lnB>
                   </a:tcPr>
                 </a:tc>
                 <a:tc>
@@ -4561,9 +4622,9 @@
                     <a:p>
                       <a:pPr algn="ctr"/>
                       <a:r>
-                        <a:rPr sz="1500" b="0">
+                        <a:rPr sz="1600" b="0">
                           <a:solidFill>
-                            <a:srgbClr val="222222"/>
+                            <a:srgbClr val="000000"/>
                           </a:solidFill>
                           <a:latin typeface="Arial"/>
                         </a:rPr>
@@ -4575,6 +4636,26 @@
                     <a:solidFill>
                       <a:srgbClr val="FFFFFF"/>
                     </a:solidFill>
+                    <a:lnL w="12700">
+                      <a:solidFill>
+                        <a:srgbClr val="000000"/>
+                      </a:solidFill>
+                    </a:lnL>
+                    <a:lnR w="12700">
+                      <a:solidFill>
+                        <a:srgbClr val="000000"/>
+                      </a:solidFill>
+                    </a:lnR>
+                    <a:lnT w="12700">
+                      <a:solidFill>
+                        <a:srgbClr val="000000"/>
+                      </a:solidFill>
+                    </a:lnT>
+                    <a:lnB w="12700">
+                      <a:solidFill>
+                        <a:srgbClr val="000000"/>
+                      </a:solidFill>
+                    </a:lnB>
                   </a:tcPr>
                 </a:tc>
                 <a:tc>
@@ -4584,9 +4665,9 @@
                     <a:p>
                       <a:pPr algn="ctr"/>
                       <a:r>
-                        <a:rPr sz="1500" b="0">
+                        <a:rPr sz="1600" b="0">
                           <a:solidFill>
-                            <a:srgbClr val="222222"/>
+                            <a:srgbClr val="000000"/>
                           </a:solidFill>
                           <a:latin typeface="Arial"/>
                         </a:rPr>
@@ -4598,6 +4679,26 @@
                     <a:solidFill>
                       <a:srgbClr val="FFFFFF"/>
                     </a:solidFill>
+                    <a:lnL w="12700">
+                      <a:solidFill>
+                        <a:srgbClr val="000000"/>
+                      </a:solidFill>
+                    </a:lnL>
+                    <a:lnR w="12700">
+                      <a:solidFill>
+                        <a:srgbClr val="000000"/>
+                      </a:solidFill>
+                    </a:lnR>
+                    <a:lnT w="12700">
+                      <a:solidFill>
+                        <a:srgbClr val="000000"/>
+                      </a:solidFill>
+                    </a:lnT>
+                    <a:lnB w="12700">
+                      <a:solidFill>
+                        <a:srgbClr val="000000"/>
+                      </a:solidFill>
+                    </a:lnB>
                   </a:tcPr>
                 </a:tc>
               </a:tr>
@@ -4609,9 +4710,9 @@
                     <a:p>
                       <a:pPr algn="ctr"/>
                       <a:r>
-                        <a:rPr sz="1500" b="0">
+                        <a:rPr sz="1600" b="0">
                           <a:solidFill>
-                            <a:srgbClr val="222222"/>
+                            <a:srgbClr val="000000"/>
                           </a:solidFill>
                           <a:latin typeface="Arial"/>
                         </a:rPr>
@@ -4621,8 +4722,28 @@
                   </a:txBody>
                   <a:tcPr>
                     <a:solidFill>
-                      <a:srgbClr val="EAF2FA"/>
+                      <a:srgbClr val="FFFFFF"/>
                     </a:solidFill>
+                    <a:lnL w="12700">
+                      <a:solidFill>
+                        <a:srgbClr val="000000"/>
+                      </a:solidFill>
+                    </a:lnL>
+                    <a:lnR w="12700">
+                      <a:solidFill>
+                        <a:srgbClr val="000000"/>
+                      </a:solidFill>
+                    </a:lnR>
+                    <a:lnT w="12700">
+                      <a:solidFill>
+                        <a:srgbClr val="000000"/>
+                      </a:solidFill>
+                    </a:lnT>
+                    <a:lnB w="12700">
+                      <a:solidFill>
+                        <a:srgbClr val="000000"/>
+                      </a:solidFill>
+                    </a:lnB>
                   </a:tcPr>
                 </a:tc>
                 <a:tc>
@@ -4632,9 +4753,9 @@
                     <a:p>
                       <a:pPr algn="ctr"/>
                       <a:r>
-                        <a:rPr sz="1500" b="0">
+                        <a:rPr sz="1600" b="0">
                           <a:solidFill>
-                            <a:srgbClr val="222222"/>
+                            <a:srgbClr val="000000"/>
                           </a:solidFill>
                           <a:latin typeface="Arial"/>
                         </a:rPr>
@@ -4644,8 +4765,28 @@
                   </a:txBody>
                   <a:tcPr>
                     <a:solidFill>
-                      <a:srgbClr val="EAF2FA"/>
+                      <a:srgbClr val="FFFFFF"/>
                     </a:solidFill>
+                    <a:lnL w="12700">
+                      <a:solidFill>
+                        <a:srgbClr val="000000"/>
+                      </a:solidFill>
+                    </a:lnL>
+                    <a:lnR w="12700">
+                      <a:solidFill>
+                        <a:srgbClr val="000000"/>
+                      </a:solidFill>
+                    </a:lnR>
+                    <a:lnT w="12700">
+                      <a:solidFill>
+                        <a:srgbClr val="000000"/>
+                      </a:solidFill>
+                    </a:lnT>
+                    <a:lnB w="12700">
+                      <a:solidFill>
+                        <a:srgbClr val="000000"/>
+                      </a:solidFill>
+                    </a:lnB>
                   </a:tcPr>
                 </a:tc>
                 <a:tc>
@@ -4655,9 +4796,9 @@
                     <a:p>
                       <a:pPr algn="ctr"/>
                       <a:r>
-                        <a:rPr sz="1500" b="0">
+                        <a:rPr sz="1600" b="0">
                           <a:solidFill>
-                            <a:srgbClr val="222222"/>
+                            <a:srgbClr val="000000"/>
                           </a:solidFill>
                           <a:latin typeface="Arial"/>
                         </a:rPr>
@@ -4667,8 +4808,28 @@
                   </a:txBody>
                   <a:tcPr>
                     <a:solidFill>
-                      <a:srgbClr val="EAF2FA"/>
+                      <a:srgbClr val="FFFFFF"/>
                     </a:solidFill>
+                    <a:lnL w="12700">
+                      <a:solidFill>
+                        <a:srgbClr val="000000"/>
+                      </a:solidFill>
+                    </a:lnL>
+                    <a:lnR w="12700">
+                      <a:solidFill>
+                        <a:srgbClr val="000000"/>
+                      </a:solidFill>
+                    </a:lnR>
+                    <a:lnT w="12700">
+                      <a:solidFill>
+                        <a:srgbClr val="000000"/>
+                      </a:solidFill>
+                    </a:lnT>
+                    <a:lnB w="12700">
+                      <a:solidFill>
+                        <a:srgbClr val="000000"/>
+                      </a:solidFill>
+                    </a:lnB>
                   </a:tcPr>
                 </a:tc>
               </a:tr>
@@ -4678,14 +4839,14 @@
       </p:graphicFrame>
       <p:sp>
         <p:nvSpPr>
-          <p:cNvPr id="26" name="TextBox 25"/>
+          <p:cNvPr id="21" name="TextBox 20"/>
           <p:cNvSpPr txBox="1"/>
           <p:nvPr/>
         </p:nvSpPr>
         <p:spPr>
           <a:xfrm>
-            <a:off x="5220000" y="10692000"/>
-            <a:ext cx="4932000" cy="216000"/>
+            <a:off x="5472000" y="10728000"/>
+            <a:ext cx="4680000" cy="900000"/>
           </a:xfrm>
           <a:prstGeom prst="rect">
             <a:avLst/>
@@ -4700,42 +4861,19 @@
           <a:p>
             <a:pPr algn="l">
               <a:spcAft>
-                <a:spcPts val="400"/>
+                <a:spcPts val="0"/>
               </a:spcAft>
             </a:pPr>
             <a:r>
-              <a:rPr sz="1100" b="0">
-                <a:solidFill>
-                  <a:srgbClr val="888888"/>
+              <a:rPr sz="1800" b="1">
+                <a:solidFill>
+                  <a:srgbClr val="000000"/>
                 </a:solidFill>
                 <a:latin typeface="Arial"/>
               </a:rPr>
-              <a:t>Messwerte aus [1], S. 91</a:t>
-            </a:r>
-          </a:p>
-        </p:txBody>
-      </p:sp>
-      <p:sp>
-        <p:nvSpPr>
-          <p:cNvPr id="27" name="TextBox 26"/>
-          <p:cNvSpPr txBox="1"/>
-          <p:nvPr/>
-        </p:nvSpPr>
-        <p:spPr>
-          <a:xfrm>
-            <a:off x="5220000" y="10980000"/>
-            <a:ext cx="4932000" cy="720000"/>
-          </a:xfrm>
-          <a:prstGeom prst="rect">
-            <a:avLst/>
-          </a:prstGeom>
-          <a:noFill/>
-        </p:spPr>
-        <p:txBody>
-          <a:bodyPr wrap="square" anchor="t" lIns="36000" rIns="36000">
-            <a:spAutoFit/>
-          </a:bodyPr>
-          <a:lstStyle/>
+              <a:t>Ergebnis:</a:t>
+            </a:r>
+          </a:p>
           <a:p>
             <a:pPr algn="l">
               <a:spcAft>
@@ -4743,71 +4881,26 @@
               </a:spcAft>
             </a:pPr>
             <a:r>
-              <a:rPr sz="1600" b="1">
-                <a:solidFill>
-                  <a:srgbClr val="222222"/>
+              <a:rPr sz="1800" b="0">
+                <a:solidFill>
+                  <a:srgbClr val="000000"/>
                 </a:solidFill>
                 <a:latin typeface="Arial"/>
               </a:rPr>
-              <a:t>Ergebnis: F · s ist immer ca. 9,8 N·m</a:t>
-            </a:r>
-          </a:p>
-          <a:p>
-            <a:pPr algn="l">
-              <a:spcAft>
-                <a:spcPts val="400"/>
-              </a:spcAft>
-            </a:pPr>
-            <a:r>
-              <a:rPr sz="1600" b="0">
-                <a:solidFill>
-                  <a:srgbClr val="222222"/>
-                </a:solidFill>
-                <a:latin typeface="Arial"/>
-              </a:rPr>
-              <a:t>→ Goldene Regel bestätigt!</a:t>
-            </a:r>
-          </a:p>
-        </p:txBody>
-      </p:sp>
-      <p:sp>
-        <p:nvSpPr>
-          <p:cNvPr id="28" name="Rectangle 27"/>
-          <p:cNvSpPr/>
+              <a:t>F · s ist bei allen Rampen ungefähr 9,8 N·m. Damit stimmt die Goldene Regel.</a:t>
+            </a:r>
+          </a:p>
+        </p:txBody>
+      </p:sp>
+      <p:sp>
+        <p:nvSpPr>
+          <p:cNvPr id="22" name="TextBox 21"/>
+          <p:cNvSpPr txBox="1"/>
           <p:nvPr/>
         </p:nvSpPr>
         <p:spPr>
           <a:xfrm>
-            <a:off x="540000" y="11772000"/>
-            <a:ext cx="9612000" cy="43200"/>
-          </a:xfrm>
-          <a:prstGeom prst="rect">
-            <a:avLst/>
-          </a:prstGeom>
-          <a:solidFill>
-            <a:srgbClr val="1F6FB2"/>
-          </a:solidFill>
-          <a:ln>
-            <a:noFill/>
-          </a:ln>
-        </p:spPr>
-        <p:txBody>
-          <a:bodyPr rtlCol="0" anchor="ctr"/>
-          <a:lstStyle/>
-          <a:p>
-            <a:pPr algn="ctr"/>
-          </a:p>
-        </p:txBody>
-      </p:sp>
-      <p:sp>
-        <p:nvSpPr>
-          <p:cNvPr id="29" name="TextBox 28"/>
-          <p:cNvSpPr txBox="1"/>
-          <p:nvPr/>
-        </p:nvSpPr>
-        <p:spPr>
-          <a:xfrm>
-            <a:off x="540000" y="11952000"/>
+            <a:off x="540000" y="11664000"/>
             <a:ext cx="9612000" cy="432000"/>
           </a:xfrm>
           <a:prstGeom prst="rect">
@@ -4827,35 +4920,35 @@
               </a:spcAft>
             </a:pPr>
             <a:r>
-              <a:rPr sz="2600" b="1">
-                <a:solidFill>
-                  <a:srgbClr val="1F6FB2"/>
+              <a:rPr sz="2800" b="1">
+                <a:solidFill>
+                  <a:srgbClr val="000000"/>
                 </a:solidFill>
                 <a:latin typeface="Arial"/>
               </a:rPr>
-              <a:t>Im Alltag</a:t>
-            </a:r>
-          </a:p>
-        </p:txBody>
-      </p:sp>
-      <p:sp>
-        <p:nvSpPr>
-          <p:cNvPr id="30" name="Rectangle 29"/>
+              <a:t>Beispiele aus dem Alltag</a:t>
+            </a:r>
+          </a:p>
+        </p:txBody>
+      </p:sp>
+      <p:sp>
+        <p:nvSpPr>
+          <p:cNvPr id="23" name="Rectangle 22"/>
           <p:cNvSpPr/>
           <p:nvPr/>
         </p:nvSpPr>
         <p:spPr>
           <a:xfrm>
-            <a:off x="540000" y="12420000"/>
-            <a:ext cx="4662000" cy="1800000"/>
+            <a:off x="540000" y="12168000"/>
+            <a:ext cx="4626000" cy="1584000"/>
           </a:xfrm>
           <a:prstGeom prst="rect">
             <a:avLst/>
           </a:prstGeom>
           <a:noFill/>
-          <a:ln w="19050">
+          <a:ln w="12700">
             <a:solidFill>
-              <a:srgbClr val="888888"/>
+              <a:srgbClr val="000000"/>
             </a:solidFill>
             <a:prstDash val="dash"/>
           </a:ln>
@@ -4866,27 +4959,27 @@
           <a:p>
             <a:pPr algn="ctr"/>
             <a:r>
-              <a:rPr sz="1400">
-                <a:solidFill>
-                  <a:srgbClr val="888888"/>
+              <a:rPr sz="1600">
+                <a:solidFill>
+                  <a:srgbClr val="000000"/>
                 </a:solidFill>
                 <a:latin typeface="Arial"/>
               </a:rPr>
-              <a:t>eigenes Foto hier einfügen</a:t>
-            </a:r>
-          </a:p>
-        </p:txBody>
-      </p:sp>
-      <p:sp>
-        <p:nvSpPr>
-          <p:cNvPr id="31" name="TextBox 30"/>
+              <a:t>Foto</a:t>
+            </a:r>
+          </a:p>
+        </p:txBody>
+      </p:sp>
+      <p:sp>
+        <p:nvSpPr>
+          <p:cNvPr id="24" name="TextBox 23"/>
           <p:cNvSpPr txBox="1"/>
           <p:nvPr/>
         </p:nvSpPr>
         <p:spPr>
           <a:xfrm>
-            <a:off x="540000" y="14256000"/>
-            <a:ext cx="4662000" cy="288000"/>
+            <a:off x="540000" y="13824000"/>
+            <a:ext cx="4626000" cy="504000"/>
           </a:xfrm>
           <a:prstGeom prst="rect">
             <a:avLst/>
@@ -4905,35 +4998,35 @@
               </a:spcAft>
             </a:pPr>
             <a:r>
-              <a:rPr sz="1400" b="0">
-                <a:solidFill>
-                  <a:srgbClr val="222222"/>
+              <a:rPr sz="1500" b="0">
+                <a:solidFill>
+                  <a:srgbClr val="000000"/>
                 </a:solidFill>
                 <a:latin typeface="Arial"/>
               </a:rPr>
-              <a:t>Bild 1: Passstraße – lange Strecke, weniger Kraft</a:t>
-            </a:r>
-          </a:p>
-        </p:txBody>
-      </p:sp>
-      <p:sp>
-        <p:nvSpPr>
-          <p:cNvPr id="32" name="Rectangle 31"/>
+              <a:t>Passstraße: Die Kurven machen den Weg länger, dafür braucht man weniger Kraft.</a:t>
+            </a:r>
+          </a:p>
+        </p:txBody>
+      </p:sp>
+      <p:sp>
+        <p:nvSpPr>
+          <p:cNvPr id="25" name="Rectangle 24"/>
           <p:cNvSpPr/>
           <p:nvPr/>
         </p:nvSpPr>
         <p:spPr>
           <a:xfrm>
-            <a:off x="5490000" y="12420000"/>
-            <a:ext cx="4662000" cy="1800000"/>
+            <a:off x="5526000" y="12168000"/>
+            <a:ext cx="4626000" cy="1584000"/>
           </a:xfrm>
           <a:prstGeom prst="rect">
             <a:avLst/>
           </a:prstGeom>
           <a:noFill/>
-          <a:ln w="19050">
+          <a:ln w="12700">
             <a:solidFill>
-              <a:srgbClr val="888888"/>
+              <a:srgbClr val="000000"/>
             </a:solidFill>
             <a:prstDash val="dash"/>
           </a:ln>
@@ -4944,27 +5037,27 @@
           <a:p>
             <a:pPr algn="ctr"/>
             <a:r>
-              <a:rPr sz="1400">
-                <a:solidFill>
-                  <a:srgbClr val="888888"/>
+              <a:rPr sz="1600">
+                <a:solidFill>
+                  <a:srgbClr val="000000"/>
                 </a:solidFill>
                 <a:latin typeface="Arial"/>
               </a:rPr>
-              <a:t>eigenes Foto hier einfügen</a:t>
-            </a:r>
-          </a:p>
-        </p:txBody>
-      </p:sp>
-      <p:sp>
-        <p:nvSpPr>
-          <p:cNvPr id="33" name="TextBox 32"/>
+              <a:t>Foto</a:t>
+            </a:r>
+          </a:p>
+        </p:txBody>
+      </p:sp>
+      <p:sp>
+        <p:nvSpPr>
+          <p:cNvPr id="26" name="TextBox 25"/>
           <p:cNvSpPr txBox="1"/>
           <p:nvPr/>
         </p:nvSpPr>
         <p:spPr>
           <a:xfrm>
-            <a:off x="5490000" y="14256000"/>
-            <a:ext cx="4662000" cy="288000"/>
+            <a:off x="5526000" y="13824000"/>
+            <a:ext cx="4626000" cy="504000"/>
           </a:xfrm>
           <a:prstGeom prst="rect">
             <a:avLst/>
@@ -4983,20 +5076,20 @@
               </a:spcAft>
             </a:pPr>
             <a:r>
-              <a:rPr sz="1400" b="0">
-                <a:solidFill>
-                  <a:srgbClr val="222222"/>
+              <a:rPr sz="1500" b="0">
+                <a:solidFill>
+                  <a:srgbClr val="000000"/>
                 </a:solidFill>
                 <a:latin typeface="Arial"/>
               </a:rPr>
-              <a:t>Bild 2: Rampe – lange Strecke, weniger Kraft</a:t>
-            </a:r>
-          </a:p>
-        </p:txBody>
-      </p:sp>
-      <p:sp>
-        <p:nvSpPr>
-          <p:cNvPr id="34" name="TextBox 33"/>
+              <a:t>Rampe: Man schiebt länger, aber leichter.</a:t>
+            </a:r>
+          </a:p>
+        </p:txBody>
+      </p:sp>
+      <p:sp>
+        <p:nvSpPr>
+          <p:cNvPr id="27" name="TextBox 26"/>
           <p:cNvSpPr txBox="1"/>
           <p:nvPr/>
         </p:nvSpPr>
@@ -5022,13 +5115,13 @@
               </a:spcAft>
             </a:pPr>
             <a:r>
-              <a:rPr sz="1100" b="0">
-                <a:solidFill>
-                  <a:srgbClr val="888888"/>
+              <a:rPr sz="1200" b="0">
+                <a:solidFill>
+                  <a:srgbClr val="000000"/>
                 </a:solidFill>
                 <a:latin typeface="Arial"/>
               </a:rPr>
-              <a:t>Quellen: [1] Universum Physik (Schulbuch), S. 90–93  ·  Fotos: eigene Aufnahmen</a:t>
+              <a:t>Quellen: Universum Physik (Schulbuch), S. 90–93; Fotos: eigene</a:t>
             </a:r>
           </a:p>
         </p:txBody>

</xml_diff>